<commit_message>
Build CA-3 submission artifacts
</commit_message>
<xml_diff>
--- a/CA3_Agentic_AI_Presentation.pptx
+++ b/CA3_Agentic_AI_Presentation.pptx
@@ -3302,7 +3302,7 @@
         <p:spPr>
           <a:xfrm>
             <a:off x="859536" y="6053328"/>
-            <a:ext cx="6400800" cy="292608"/>
+            <a:ext cx="7406640" cy="292608"/>
           </a:xfrm>
           <a:prstGeom prst="rect">
             <a:avLst/>
@@ -3316,7 +3316,7 @@
           <a:lstStyle/>
           <a:p>
             <a:pPr>
-              <a:defRPr sz="1100" b="1">
+              <a:defRPr sz="1000" b="1">
                 <a:solidFill>
                   <a:srgbClr val="9DE5DA"/>
                 </a:solidFill>
@@ -3324,7 +3324,7 @@
               </a:defRPr>
             </a:pPr>
             <a:r>
-              <a:t>Aryan Gawande  ·  Education &amp; Career Development</a:t>
+              <a:t>Aryan Gawande  ·  PRN: 24070126223  ·  Education &amp; Career Development</a:t>
             </a:r>
           </a:p>
         </p:txBody>

</xml_diff>